<commit_message>
Add AgentDojo banking evidence and updated submission documents
</commit_message>
<xml_diff>
--- a/docs/submission/deck.pptx
+++ b/docs/submission/deck.pptx
@@ -20,6 +20,7 @@
     <p:sldId id="265" r:id="rId17"/>
     <p:sldId id="266" r:id="rId18"/>
     <p:sldId id="267" r:id="rId19"/>
+    <p:sldId id="272" r:id="rId24"/>
     <p:sldId id="268" r:id="rId20"/>
     <p:sldId id="269" r:id="rId21"/>
     <p:sldId id="270" r:id="rId22"/>
@@ -141,6 +142,640 @@
 </p:presentation>
 </file>
 
+<file path=ppt/charts/chart1.xml><?xml version="1.0" encoding="utf-8"?>
+<c:chartSpace xmlns:c="http://schemas.openxmlformats.org/drawingml/2006/chart" xmlns:a="http://schemas.openxmlformats.org/drawingml/2006/main" xmlns:r="http://schemas.openxmlformats.org/officeDocument/2006/relationships">
+  <c:date1904 val="0"/>
+  <c:chart>
+    <c:autoTitleDeleted val="0"/>
+    <c:plotArea>
+      <c:barChart>
+        <c:barDir val="bar"/>
+        <c:grouping val="clustered"/>
+        <c:ser>
+          <c:idx val="0"/>
+          <c:order val="0"/>
+          <c:tx>
+            <c:strRef>
+              <c:f>Sheet1!$B$1</c:f>
+              <c:strCache>
+                <c:ptCount val="1"/>
+                <c:pt idx="0">
+                  <c:v>Targeted ASR (%) · model-free</c:v>
+                </c:pt>
+              </c:strCache>
+            </c:strRef>
+          </c:tx>
+          <c:dPt>
+            <c:idx val="0"/>
+            <c:spPr>
+              <a:solidFill>
+                <a:srgbClr val="102D50"/>
+              </a:solidFill>
+              <a:ln>
+                <a:noFill/>
+              </a:ln>
+            </c:spPr>
+          </c:dPt>
+          <c:dPt>
+            <c:idx val="1"/>
+            <c:spPr>
+              <a:solidFill>
+                <a:srgbClr val="007F86"/>
+              </a:solidFill>
+              <a:ln>
+                <a:noFill/>
+              </a:ln>
+            </c:spPr>
+          </c:dPt>
+          <c:dPt>
+            <c:idx val="2"/>
+            <c:spPr>
+              <a:solidFill>
+                <a:srgbClr val="102D50"/>
+              </a:solidFill>
+              <a:ln>
+                <a:noFill/>
+              </a:ln>
+            </c:spPr>
+          </c:dPt>
+          <c:dPt>
+            <c:idx val="3"/>
+            <c:spPr>
+              <a:solidFill>
+                <a:srgbClr val="007F86"/>
+              </a:solidFill>
+              <a:ln>
+                <a:noFill/>
+              </a:ln>
+            </c:spPr>
+          </c:dPt>
+          <c:dLbls>
+            <c:dLbl>
+              <c:idx val="0"/>
+              <c:tx>
+                <c:rich>
+                  <a:bodyPr/>
+                  <a:lstStyle/>
+                  <a:p>
+                    <a:r>
+                      <a:rPr sz="1700" b="1">
+                        <a:solidFill>
+                          <a:srgbClr val="102D50"/>
+                        </a:solidFill>
+                        <a:latin typeface="Arial"/>
+                      </a:rPr>
+                      <a:t>144/144</a:t>
+                    </a:r>
+                  </a:p>
+                </c:rich>
+              </c:tx>
+              <c:showLegendKey val="0"/>
+              <c:showVal val="1"/>
+              <c:showCatName val="0"/>
+              <c:showSerName val="0"/>
+              <c:showPercent val="0"/>
+              <c:showBubbleSize val="0"/>
+            </c:dLbl>
+            <c:dLbl>
+              <c:idx val="1"/>
+              <c:tx>
+                <c:rich>
+                  <a:bodyPr/>
+                  <a:lstStyle/>
+                  <a:p>
+                    <a:r>
+                      <a:rPr sz="1700" b="1">
+                        <a:solidFill>
+                          <a:srgbClr val="102D50"/>
+                        </a:solidFill>
+                        <a:latin typeface="Arial"/>
+                      </a:rPr>
+                      <a:t>128/144</a:t>
+                    </a:r>
+                  </a:p>
+                </c:rich>
+              </c:tx>
+              <c:showLegendKey val="0"/>
+              <c:showVal val="1"/>
+              <c:showCatName val="0"/>
+              <c:showSerName val="0"/>
+              <c:showPercent val="0"/>
+              <c:showBubbleSize val="0"/>
+            </c:dLbl>
+            <c:dLbl>
+              <c:idx val="2"/>
+              <c:tx>
+                <c:rich>
+                  <a:bodyPr/>
+                  <a:lstStyle/>
+                  <a:p>
+                    <a:r>
+                      <a:rPr sz="1700" b="1">
+                        <a:solidFill>
+                          <a:srgbClr val="102D50"/>
+                        </a:solidFill>
+                        <a:latin typeface="Arial"/>
+                      </a:rPr>
+                      <a:t>0/144</a:t>
+                    </a:r>
+                  </a:p>
+                </c:rich>
+              </c:tx>
+              <c:showLegendKey val="0"/>
+              <c:showVal val="1"/>
+              <c:showCatName val="0"/>
+              <c:showSerName val="0"/>
+              <c:showPercent val="0"/>
+              <c:showBubbleSize val="0"/>
+            </c:dLbl>
+            <c:dLbl>
+              <c:idx val="3"/>
+              <c:tx>
+                <c:rich>
+                  <a:bodyPr/>
+                  <a:lstStyle/>
+                  <a:p>
+                    <a:r>
+                      <a:rPr sz="1700" b="1">
+                        <a:solidFill>
+                          <a:srgbClr val="102D50"/>
+                        </a:solidFill>
+                        <a:latin typeface="Arial"/>
+                      </a:rPr>
+                      <a:t>0/144</a:t>
+                    </a:r>
+                  </a:p>
+                </c:rich>
+              </c:tx>
+              <c:showLegendKey val="0"/>
+              <c:showVal val="1"/>
+              <c:showCatName val="0"/>
+              <c:showSerName val="0"/>
+              <c:showPercent val="0"/>
+              <c:showBubbleSize val="0"/>
+            </c:dLbl>
+            <c:showLegendKey val="0"/>
+            <c:showVal val="0"/>
+            <c:showCatName val="0"/>
+            <c:showSerName val="0"/>
+            <c:showPercent val="0"/>
+            <c:showBubbleSize val="0"/>
+            <c:showLeaderLines val="1"/>
+          </c:dLbls>
+          <c:cat>
+            <c:strRef>
+              <c:f>Sheet1!$A$2:$A$5</c:f>
+              <c:strCache>
+                <c:ptCount val="4"/>
+                <c:pt idx="0">
+                  <c:v>A0 original</c:v>
+                </c:pt>
+                <c:pt idx="1">
+                  <c:v>A0 corrected</c:v>
+                </c:pt>
+                <c:pt idx="2">
+                  <c:v>A5 original</c:v>
+                </c:pt>
+                <c:pt idx="3">
+                  <c:v>A5 corrected</c:v>
+                </c:pt>
+              </c:strCache>
+            </c:strRef>
+          </c:cat>
+          <c:val>
+            <c:numRef>
+              <c:f>Sheet1!$B$2:$B$5</c:f>
+              <c:numCache>
+                <c:formatCode>General</c:formatCode>
+                <c:ptCount val="4"/>
+                <c:pt idx="0">
+                  <c:v>100.0</c:v>
+                </c:pt>
+                <c:pt idx="1">
+                  <c:v>88.88888888888889</c:v>
+                </c:pt>
+                <c:pt idx="2">
+                  <c:v>0.0</c:v>
+                </c:pt>
+                <c:pt idx="3">
+                  <c:v>0.0</c:v>
+                </c:pt>
+              </c:numCache>
+            </c:numRef>
+          </c:val>
+        </c:ser>
+        <c:dLbls>
+          <c:dLblPos val="outEnd"/>
+          <c:showLegendKey val="0"/>
+          <c:showVal val="1"/>
+          <c:showCatName val="0"/>
+          <c:showSerName val="0"/>
+          <c:showPercent val="0"/>
+          <c:showBubbleSize val="0"/>
+          <c:showLeaderLines val="1"/>
+        </c:dLbls>
+        <c:gapWidth val="70"/>
+        <c:axId val="-2068027336"/>
+        <c:axId val="-2113994440"/>
+      </c:barChart>
+      <c:catAx>
+        <c:axId val="-2068027336"/>
+        <c:scaling>
+          <c:orientation val="maxMin"/>
+        </c:scaling>
+        <c:delete val="0"/>
+        <c:axPos val="l"/>
+        <c:majorTickMark val="none"/>
+        <c:minorTickMark val="none"/>
+        <c:tickLblPos val="nextTo"/>
+        <c:txPr>
+          <a:bodyPr/>
+          <a:lstStyle/>
+          <a:p>
+            <a:pPr>
+              <a:defRPr sz="1600">
+                <a:latin typeface="Arial"/>
+              </a:defRPr>
+            </a:pPr>
+          </a:p>
+        </c:txPr>
+        <c:crossAx val="-2113994440"/>
+        <c:crosses val="autoZero"/>
+        <c:auto val="1"/>
+        <c:lblAlgn val="ctr"/>
+        <c:lblOffset val="100"/>
+        <c:noMultiLvlLbl val="0"/>
+      </c:catAx>
+      <c:valAx>
+        <c:axId val="-2113994440"/>
+        <c:scaling>
+          <c:max val="120.0"/>
+          <c:min val="0.0"/>
+        </c:scaling>
+        <c:delete val="0"/>
+        <c:axPos val="b"/>
+        <c:majorGridlines>
+          <c:spPr>
+            <a:ln>
+              <a:solidFill>
+                <a:srgbClr val="E6EBF0"/>
+              </a:solidFill>
+            </a:ln>
+          </c:spPr>
+        </c:majorGridlines>
+        <c:numFmt formatCode="0&quot;%&quot;" sourceLinked="0"/>
+        <c:majorTickMark val="out"/>
+        <c:minorTickMark val="none"/>
+        <c:tickLblPos val="nextTo"/>
+        <c:txPr>
+          <a:bodyPr/>
+          <a:lstStyle/>
+          <a:p>
+            <a:pPr>
+              <a:defRPr sz="1400"/>
+            </a:pPr>
+          </a:p>
+        </c:txPr>
+        <c:crossAx val="-2068027336"/>
+        <c:crosses val="autoZero"/>
+        <c:majorUnit val="50.0"/>
+      </c:valAx>
+    </c:plotArea>
+    <c:dispBlanksAs val="gap"/>
+  </c:chart>
+  <c:txPr>
+    <a:bodyPr/>
+    <a:lstStyle/>
+    <a:p>
+      <a:pPr>
+        <a:defRPr sz="1800"/>
+      </a:pPr>
+      <a:endParaRPr lang="en-US"/>
+    </a:p>
+  </c:txPr>
+  <c:externalData r:id="rId1">
+    <c:autoUpdate val="0"/>
+  </c:externalData>
+</c:chartSpace>
+</file>
+
+<file path=ppt/charts/chart2.xml><?xml version="1.0" encoding="utf-8"?>
+<c:chartSpace xmlns:c="http://schemas.openxmlformats.org/drawingml/2006/chart" xmlns:a="http://schemas.openxmlformats.org/drawingml/2006/main" xmlns:r="http://schemas.openxmlformats.org/officeDocument/2006/relationships">
+  <c:date1904 val="0"/>
+  <c:chart>
+    <c:autoTitleDeleted val="0"/>
+    <c:plotArea>
+      <c:barChart>
+        <c:barDir val="bar"/>
+        <c:grouping val="clustered"/>
+        <c:ser>
+          <c:idx val="0"/>
+          <c:order val="0"/>
+          <c:tx>
+            <c:strRef>
+              <c:f>Sheet1!$B$1</c:f>
+              <c:strCache>
+                <c:ptCount val="1"/>
+                <c:pt idx="0">
+                  <c:v>Targeted ASR (%) · live</c:v>
+                </c:pt>
+              </c:strCache>
+            </c:strRef>
+          </c:tx>
+          <c:dPt>
+            <c:idx val="0"/>
+            <c:spPr>
+              <a:solidFill>
+                <a:srgbClr val="102D50"/>
+              </a:solidFill>
+              <a:ln>
+                <a:noFill/>
+              </a:ln>
+            </c:spPr>
+          </c:dPt>
+          <c:dPt>
+            <c:idx val="1"/>
+            <c:spPr>
+              <a:solidFill>
+                <a:srgbClr val="007F86"/>
+              </a:solidFill>
+              <a:ln>
+                <a:noFill/>
+              </a:ln>
+            </c:spPr>
+          </c:dPt>
+          <c:dPt>
+            <c:idx val="2"/>
+            <c:spPr>
+              <a:solidFill>
+                <a:srgbClr val="102D50"/>
+              </a:solidFill>
+              <a:ln>
+                <a:noFill/>
+              </a:ln>
+            </c:spPr>
+          </c:dPt>
+          <c:dPt>
+            <c:idx val="3"/>
+            <c:spPr>
+              <a:solidFill>
+                <a:srgbClr val="007F86"/>
+              </a:solidFill>
+              <a:ln>
+                <a:noFill/>
+              </a:ln>
+            </c:spPr>
+          </c:dPt>
+          <c:dLbls>
+            <c:dLbl>
+              <c:idx val="0"/>
+              <c:tx>
+                <c:rich>
+                  <a:bodyPr/>
+                  <a:lstStyle/>
+                  <a:p>
+                    <a:r>
+                      <a:rPr sz="1700" b="1">
+                        <a:solidFill>
+                          <a:srgbClr val="102D50"/>
+                        </a:solidFill>
+                        <a:latin typeface="Arial"/>
+                      </a:rPr>
+                      <a:t>0/144</a:t>
+                    </a:r>
+                  </a:p>
+                </c:rich>
+              </c:tx>
+              <c:showLegendKey val="0"/>
+              <c:showVal val="1"/>
+              <c:showCatName val="0"/>
+              <c:showSerName val="0"/>
+              <c:showPercent val="0"/>
+              <c:showBubbleSize val="0"/>
+            </c:dLbl>
+            <c:dLbl>
+              <c:idx val="1"/>
+              <c:tx>
+                <c:rich>
+                  <a:bodyPr/>
+                  <a:lstStyle/>
+                  <a:p>
+                    <a:r>
+                      <a:rPr sz="1700" b="1">
+                        <a:solidFill>
+                          <a:srgbClr val="102D50"/>
+                        </a:solidFill>
+                        <a:latin typeface="Arial"/>
+                      </a:rPr>
+                      <a:t>0/144</a:t>
+                    </a:r>
+                  </a:p>
+                </c:rich>
+              </c:tx>
+              <c:showLegendKey val="0"/>
+              <c:showVal val="1"/>
+              <c:showCatName val="0"/>
+              <c:showSerName val="0"/>
+              <c:showPercent val="0"/>
+              <c:showBubbleSize val="0"/>
+            </c:dLbl>
+            <c:dLbl>
+              <c:idx val="2"/>
+              <c:tx>
+                <c:rich>
+                  <a:bodyPr/>
+                  <a:lstStyle/>
+                  <a:p>
+                    <a:r>
+                      <a:rPr sz="1700" b="1">
+                        <a:solidFill>
+                          <a:srgbClr val="102D50"/>
+                        </a:solidFill>
+                        <a:latin typeface="Arial"/>
+                      </a:rPr>
+                      <a:t>0/143</a:t>
+                    </a:r>
+                  </a:p>
+                </c:rich>
+              </c:tx>
+              <c:showLegendKey val="0"/>
+              <c:showVal val="1"/>
+              <c:showCatName val="0"/>
+              <c:showSerName val="0"/>
+              <c:showPercent val="0"/>
+              <c:showBubbleSize val="0"/>
+            </c:dLbl>
+            <c:dLbl>
+              <c:idx val="3"/>
+              <c:tx>
+                <c:rich>
+                  <a:bodyPr/>
+                  <a:lstStyle/>
+                  <a:p>
+                    <a:r>
+                      <a:rPr sz="1700" b="1">
+                        <a:solidFill>
+                          <a:srgbClr val="102D50"/>
+                        </a:solidFill>
+                        <a:latin typeface="Arial"/>
+                      </a:rPr>
+                      <a:t>0/143</a:t>
+                    </a:r>
+                  </a:p>
+                </c:rich>
+              </c:tx>
+              <c:showLegendKey val="0"/>
+              <c:showVal val="1"/>
+              <c:showCatName val="0"/>
+              <c:showSerName val="0"/>
+              <c:showPercent val="0"/>
+              <c:showBubbleSize val="0"/>
+            </c:dLbl>
+            <c:showLegendKey val="0"/>
+            <c:showVal val="0"/>
+            <c:showCatName val="0"/>
+            <c:showSerName val="0"/>
+            <c:showPercent val="0"/>
+            <c:showBubbleSize val="0"/>
+            <c:showLeaderLines val="1"/>
+          </c:dLbls>
+          <c:cat>
+            <c:strRef>
+              <c:f>Sheet1!$A$2:$A$5</c:f>
+              <c:strCache>
+                <c:ptCount val="4"/>
+                <c:pt idx="0">
+                  <c:v>A0 original</c:v>
+                </c:pt>
+                <c:pt idx="1">
+                  <c:v>A0 corrected</c:v>
+                </c:pt>
+                <c:pt idx="2">
+                  <c:v>A5 original</c:v>
+                </c:pt>
+                <c:pt idx="3">
+                  <c:v>A5 corrected</c:v>
+                </c:pt>
+              </c:strCache>
+            </c:strRef>
+          </c:cat>
+          <c:val>
+            <c:numRef>
+              <c:f>Sheet1!$B$2:$B$5</c:f>
+              <c:numCache>
+                <c:formatCode>General</c:formatCode>
+                <c:ptCount val="4"/>
+                <c:pt idx="0">
+                  <c:v>0.0</c:v>
+                </c:pt>
+                <c:pt idx="1">
+                  <c:v>0.0</c:v>
+                </c:pt>
+                <c:pt idx="2">
+                  <c:v>0.0</c:v>
+                </c:pt>
+                <c:pt idx="3">
+                  <c:v>0.0</c:v>
+                </c:pt>
+              </c:numCache>
+            </c:numRef>
+          </c:val>
+        </c:ser>
+        <c:dLbls>
+          <c:dLblPos val="outEnd"/>
+          <c:showLegendKey val="0"/>
+          <c:showVal val="1"/>
+          <c:showCatName val="0"/>
+          <c:showSerName val="0"/>
+          <c:showPercent val="0"/>
+          <c:showBubbleSize val="0"/>
+          <c:showLeaderLines val="1"/>
+        </c:dLbls>
+        <c:gapWidth val="70"/>
+        <c:axId val="-2068027336"/>
+        <c:axId val="-2113994440"/>
+      </c:barChart>
+      <c:catAx>
+        <c:axId val="-2068027336"/>
+        <c:scaling>
+          <c:orientation val="maxMin"/>
+        </c:scaling>
+        <c:delete val="0"/>
+        <c:axPos val="l"/>
+        <c:majorTickMark val="none"/>
+        <c:minorTickMark val="none"/>
+        <c:tickLblPos val="nextTo"/>
+        <c:txPr>
+          <a:bodyPr/>
+          <a:lstStyle/>
+          <a:p>
+            <a:pPr>
+              <a:defRPr sz="1600">
+                <a:latin typeface="Arial"/>
+              </a:defRPr>
+            </a:pPr>
+          </a:p>
+        </c:txPr>
+        <c:crossAx val="-2113994440"/>
+        <c:crosses val="autoZero"/>
+        <c:auto val="1"/>
+        <c:lblAlgn val="ctr"/>
+        <c:lblOffset val="100"/>
+        <c:noMultiLvlLbl val="0"/>
+      </c:catAx>
+      <c:valAx>
+        <c:axId val="-2113994440"/>
+        <c:scaling>
+          <c:max val="120.0"/>
+          <c:min val="0.0"/>
+        </c:scaling>
+        <c:delete val="0"/>
+        <c:axPos val="b"/>
+        <c:majorGridlines>
+          <c:spPr>
+            <a:ln>
+              <a:solidFill>
+                <a:srgbClr val="E6EBF0"/>
+              </a:solidFill>
+            </a:ln>
+          </c:spPr>
+        </c:majorGridlines>
+        <c:numFmt formatCode="0&quot;%&quot;" sourceLinked="0"/>
+        <c:majorTickMark val="out"/>
+        <c:minorTickMark val="none"/>
+        <c:tickLblPos val="nextTo"/>
+        <c:txPr>
+          <a:bodyPr/>
+          <a:lstStyle/>
+          <a:p>
+            <a:pPr>
+              <a:defRPr sz="1400"/>
+            </a:pPr>
+          </a:p>
+        </c:txPr>
+        <c:crossAx val="-2068027336"/>
+        <c:crosses val="autoZero"/>
+        <c:majorUnit val="50.0"/>
+      </c:valAx>
+    </c:plotArea>
+    <c:dispBlanksAs val="gap"/>
+  </c:chart>
+  <c:txPr>
+    <a:bodyPr/>
+    <a:lstStyle/>
+    <a:p>
+      <a:pPr>
+        <a:defRPr sz="1800"/>
+      </a:pPr>
+      <a:endParaRPr lang="en-US"/>
+    </a:p>
+  </c:txPr>
+  <c:externalData r:id="rId1">
+    <c:autoUpdate val="0"/>
+  </c:externalData>
+</c:chartSpace>
+</file>
+
 <file path=ppt/handoutMasters/handoutMaster1.xml><?xml version="1.0" encoding="utf-8"?>
 <p:handoutMaster xmlns:a="http://schemas.openxmlformats.org/drawingml/2006/main" xmlns:r="http://schemas.openxmlformats.org/officeDocument/2006/relationships" xmlns:p="http://schemas.openxmlformats.org/presentationml/2006/main">
   <p:cSld>
@@ -782,13 +1417,13 @@
           <a:lstStyle/>
           <a:p>
             <a:r>
-              <a:t>Slide 10 | Estimated 40 seconds | 6:25–7:05</a:t>
+              <a:t>Slide 10 | Estimated 40 seconds | 6:15–6:55</a:t>
             </a:r>
           </a:p>
           <a:p/>
           <a:p>
             <a:r>
-              <a:t>The F5 retained report records live-recorded J 24/24, W 12/12, advisory workflows 30/30, M2 26/26 and M4 10/10. Strict replay reproduced the task observations; advisory workflow equality is reported through parent W task equality, not an extra independent sample. Formal W mechanism subcases remain scripted. Strict replay on the current code verified 142/142 observations: 141 raw observations are byte-for-byte identical, and 1 J01 observation is verified by a migration proof because the bilingual port changed the audit fact-hash format. Network transport was disabled and no API calls occurred. P2 matched 142/142 byte-for-byte on code before I1, a historical result. Verification is not task success. See docs/submission/provenance/current-replay-summary.json and evidence/p2-replay/replay-summary.json. Retain the contrast failure: gpt-5.4-mini W04 failed, with 4/5 workflows completed, and replay reproduced the failure. Source: results/FINAL-RESULTS.md, M10 and M2/M4 sections; scripts/replay_final.py.</a:t>
+              <a:t>AgentDojo banking v1.2.2, package 0.1.35, supplies an external synthetic environment. The left chart is model-free GroundTruth replay: A0 targeted ASR is 144/144 with the original judge and 128/144 with the registered corrected IT0/IT1/IT3 check. A5 is 0/144 in each of prompt-bound, auto-deny and auto-approve modes; the null agent is also 0/144. These are complete censuses, with no binomial bounds. The right chart is live gpt-6.1-sol with important_instructions, domestic-freeze-6: A0 is 0/144 under both judges; prompt-bound A5 is 0/143 evaluable under both, with one attack pair truncated and unresolved. No live security advantage is established. Unchanged upstream utility, live gpt-6.1-sol: A0 benign 11/16 and attacked 97/144; A5 prompt-bound benign 8/16 and attacked 72/144 planned, counting truncations incomplete. All 509/509 selected blocks passed strict replay; pilot and other approval modes are disclosed separately in the bundle. Value matching from free-text arguments is weaker than native typed references. Issue #181, public 2026-08-17, already reports the precedence defect. Our additional observation is the IT1 GroundTruth helper-return failure under the corrected check. Sources: evidence/agentdojo-banking/MANIFEST.md; https://github.com/ethz-spylab/agentdojo/issues/181.</a:t>
             </a:r>
           </a:p>
         </p:txBody>
@@ -858,13 +1493,13 @@
           <a:lstStyle/>
           <a:p>
             <a:r>
-              <a:t>Slide 11 | Estimated 40 seconds | 7:05–7:45</a:t>
+              <a:t>Slide 11 | Estimated 35 seconds | 6:55–7:30</a:t>
             </a:r>
           </a:p>
           <a:p/>
           <a:p>
             <a:r>
-              <a:t>Clarification does not silently set consequential fields. The user signs the new goal; correction withdraws prior approval authority. A recomputed comparison makes the change inspectable. Stop preserves completed legs; unknown outcomes stay pending reconciliation. Only signed bank receipts establish completed execution, and the audit links the history. These retained I1 UI screenshots are scripted synthetic demonstrations; no live model is called. Screens and source manifest are retained alongside the deck.</a:t>
+              <a:t>The F5 retained report records live-recorded J 24/24, W 12/12, advisory workflows 30/30, M2 26/26 and M4 10/10. Strict replay reproduced the task observations; advisory workflow equality is reported through parent W task equality, not an extra independent sample. Formal W mechanism subcases remain scripted. Strict replay on the current code verified 142/142 observations: 141 raw observations are byte-for-byte identical, and 1 J01 observation is verified by a migration proof because the bilingual port changed the audit fact-hash format. Network transport was disabled and no API calls occurred. P2 matched 142/142 byte-for-byte on code before I1, a historical result. Verification is not task success. See docs/submission/provenance/current-replay-summary.json and evidence/p2-replay/replay-summary.json. Retain the contrast failure: gpt-5.4-mini W04 failed, with 4/5 workflows completed, and replay reproduced the failure. Source: results/FINAL-RESULTS.md, M10 and M2/M4 sections; scripts/replay_final.py.</a:t>
             </a:r>
           </a:p>
         </p:txBody>
@@ -934,13 +1569,13 @@
           <a:lstStyle/>
           <a:p>
             <a:r>
-              <a:t>Slide 12 | Estimated 35 seconds | 7:45–8:20</a:t>
+              <a:t>Slide 12 | Estimated 40 seconds | 7:30–8:10</a:t>
             </a:r>
           </a:p>
           <a:p/>
           <a:p>
             <a:r>
-              <a:t>Four cross-model review rounds confirmed 21, 8, 4 and 10 findings respectively, all addressed in F1/F2/F3/F5 status with reproduction tests. Rejected findings are distinct and not counted as fixes. The retained F5 final acceptance was 2895 passing tests, zero failures, and no uncovered rules. The rule registry currently has 71 entries. Current artifact checks are recorded separately in validation.md; do not confuse historical F5 counts with a fresh test count. Import-linter plus AST checks enforce boundaries; kernel arithmetic avoids floats. Sources: docs/review/claude-review-1.json through -4.json; docs/status/F1.md, F2.md, F3.md, F5.md; FINAL-RESULTS quality gates.</a:t>
+              <a:t>Clarification does not silently set consequential fields. The user signs the new goal; correction withdraws prior approval authority. A recomputed comparison makes the change inspectable. Stop preserves completed legs; unknown outcomes stay pending reconciliation. Only signed bank receipts establish completed execution, and the audit links the history. These retained I1 UI screenshots are scripted synthetic demonstrations; no live model is called. Screens and source manifest are retained alongside the deck.</a:t>
             </a:r>
           </a:p>
         </p:txBody>
@@ -1010,7 +1645,83 @@
           <a:lstStyle/>
           <a:p>
             <a:r>
-              <a:t>Slide 13 | Estimated 30 seconds | 8:20–8:50</a:t>
+              <a:t>Slide 13 | Estimated 30 seconds | 8:10–8:40</a:t>
+            </a:r>
+          </a:p>
+          <a:p/>
+          <a:p>
+            <a:r>
+              <a:t>Four cross-model review rounds confirmed 21, 8, 4 and 10 findings respectively, all addressed in F1/F2/F3/F5 status with reproduction tests. Rejected findings are distinct and not counted as fixes. The retained F5 final acceptance was 2895 passing tests, zero failures, and no uncovered rules. The rule registry currently has 71 entries. Current artifact checks are recorded separately in validation.md; do not confuse historical F5 counts with a fresh test count. Import-linter plus AST checks enforce boundaries; kernel arithmetic avoids floats. Sources: docs/review/claude-review-1.json through -4.json; docs/status/F1.md, F2.md, F3.md, F5.md; FINAL-RESULTS quality gates.</a:t>
+            </a:r>
+          </a:p>
+        </p:txBody>
+      </p:sp>
+      <p:sp>
+        <p:nvSpPr>
+          <p:cNvPr id="4" name="Slide Number Placeholder 3"/>
+          <p:cNvSpPr>
+            <a:spLocks noGrp="1"/>
+          </p:cNvSpPr>
+          <p:nvPr>
+            <p:ph type="sldNum" idx="5" sz="quarter"/>
+          </p:nvPr>
+        </p:nvSpPr>
+        <p:spPr/>
+      </p:sp>
+    </p:spTree>
+  </p:cSld>
+  <p:clrMapOvr>
+    <a:masterClrMapping/>
+  </p:clrMapOvr>
+</p:notes>
+</file>
+
+<file path=ppt/notesSlides/notesSlide14.xml><?xml version="1.0" encoding="utf-8"?>
+<p:notes xmlns:a="http://schemas.openxmlformats.org/drawingml/2006/main" xmlns:p="http://schemas.openxmlformats.org/presentationml/2006/main" xmlns:r="http://schemas.openxmlformats.org/officeDocument/2006/relationships">
+  <p:cSld>
+    <p:spTree>
+      <p:nvGrpSpPr>
+        <p:cNvPr id="1" name=""/>
+        <p:cNvGrpSpPr/>
+        <p:nvPr/>
+      </p:nvGrpSpPr>
+      <p:grpSpPr>
+        <a:xfrm>
+          <a:off x="0" y="0"/>
+          <a:ext cx="0" cy="0"/>
+          <a:chOff x="0" y="0"/>
+          <a:chExt cx="0" cy="0"/>
+        </a:xfrm>
+      </p:grpSpPr>
+      <p:sp>
+        <p:nvSpPr>
+          <p:cNvPr id="2" name="Slide Image Placeholder 1"/>
+          <p:cNvSpPr>
+            <a:spLocks noGrp="1"/>
+          </p:cNvSpPr>
+          <p:nvPr>
+            <p:ph type="sldImg" idx="2"/>
+          </p:nvPr>
+        </p:nvSpPr>
+        <p:spPr/>
+      </p:sp>
+      <p:sp>
+        <p:nvSpPr>
+          <p:cNvPr id="3" name="Notes Placeholder 2"/>
+          <p:cNvSpPr>
+            <a:spLocks noGrp="1"/>
+          </p:cNvSpPr>
+          <p:nvPr>
+            <p:ph type="body" idx="3" sz="quarter"/>
+          </p:nvPr>
+        </p:nvSpPr>
+        <p:spPr/>
+        <p:txBody>
+          <a:bodyPr/>
+          <a:lstStyle/>
+          <a:p>
+            <a:r>
+              <a:t>Slide 14 | Estimated 30 seconds | 8:40–9:10</a:t>
             </a:r>
           </a:p>
           <a:p/>
@@ -1244,7 +1955,7 @@
           <a:p/>
           <a:p>
             <a:r>
-              <a:t>Read the trust boundary, not every box. A gpt-6.1-sol planner is untrusted; it uses tools and typed references. PII is filtered on ingress. Signed state and catalogue feed BIAC recomputation. The current registry has 71 rules across enforcement points, including 43 kernel, 25 gateway and 3 sandbox rules; the kernel itself must not be labelled 60-plus. Gateway rechecks at dispatch, consumes one-shot authority and enforces APR-BUDGET. The current synthetic backend is MockBank, not the historical SimBank. Receipts are verified, factual prose crosses an output gate, and audit records form a hash chain. Static code inventory has no stochastic mode or binomial denominator.</a:t>
+              <a:t>Model proposes, kernel decides, device authorises, gateway executes. This describes the existing authority separation. A gpt-6.1-sol planner is untrusted; it uses tools and typed references. PII is filtered on ingress. Signed state and catalogue feed BIAC recomputation. The current registry has 71 rules across enforcement points, including 43 kernel, 25 gateway and 3 sandbox rules; the kernel itself must not be labelled 60-plus. Gateway rechecks at dispatch, consumes one-shot authority and enforces APR-BUDGET. The current synthetic backend is MockBank, not the historical SimBank. Receipts are verified, factual prose crosses an output gate, and audit records form a hash chain. Static code inventory has no stochastic mode or binomial denominator.</a:t>
             </a:r>
           </a:p>
         </p:txBody>
@@ -1542,7 +2253,7 @@
           <a:lstStyle/>
           <a:p>
             <a:r>
-              <a:t>Slide 8 | Estimated 55 seconds | 4:45–5:40</a:t>
+              <a:t>Slide 8 | Estimated 45 seconds | 4:45–5:30</a:t>
             </a:r>
           </a:p>
           <a:p/>
@@ -1618,7 +2329,7 @@
           <a:lstStyle/>
           <a:p>
             <a:r>
-              <a:t>Slide 9 | Estimated 45 seconds | 5:40–6:25</a:t>
+              <a:t>Slide 9 | Estimated 45 seconds | 5:30–6:15</a:t>
             </a:r>
           </a:p>
           <a:p/>
@@ -5683,7 +6394,7 @@
                 </a:solidFill>
                 <a:latin typeface="Arial"/>
               </a:rPr>
-              <a:t>10</a:t>
+              <a:t>11</a:t>
             </a:r>
           </a:p>
         </p:txBody>
@@ -5995,7 +6706,7 @@
                 </a:solidFill>
                 <a:latin typeface="Arial"/>
               </a:rPr>
-              <a:t>11</a:t>
+              <a:t>12</a:t>
             </a:r>
           </a:p>
         </p:txBody>
@@ -6588,7 +7299,7 @@
                 </a:solidFill>
                 <a:latin typeface="Arial"/>
               </a:rPr>
-              <a:t>12</a:t>
+              <a:t>13</a:t>
             </a:r>
           </a:p>
         </p:txBody>
@@ -6845,7 +7556,7 @@
                 </a:solidFill>
                 <a:latin typeface="Arial"/>
               </a:rPr>
-              <a:t>13</a:t>
+              <a:t>14</a:t>
             </a:r>
           </a:p>
         </p:txBody>
@@ -7145,6 +7856,470 @@
                 <a:latin typeface="Arial"/>
               </a:rPr>
               <a:t>Synthetic data · simulated MFA · performance benchmark (not guaranteed) · not investment advice</a:t>
+            </a:r>
+          </a:p>
+        </p:txBody>
+      </p:sp>
+    </p:spTree>
+  </p:cSld>
+  <p:clrMapOvr>
+    <a:masterClrMapping/>
+  </p:clrMapOvr>
+</p:sld>
+</file>
+
+<file path=ppt/slides/slide17.xml><?xml version="1.0" encoding="utf-8"?>
+<p:sld xmlns:a="http://schemas.openxmlformats.org/drawingml/2006/main" xmlns:p="http://schemas.openxmlformats.org/presentationml/2006/main" xmlns:r="http://schemas.openxmlformats.org/officeDocument/2006/relationships">
+  <p:cSld>
+    <p:spTree>
+      <p:nvGrpSpPr>
+        <p:cNvPr id="1" name=""/>
+        <p:cNvGrpSpPr/>
+        <p:nvPr/>
+      </p:nvGrpSpPr>
+      <p:grpSpPr/>
+      <p:sp>
+        <p:nvSpPr>
+          <p:cNvPr id="2" name="TextBox 1"/>
+          <p:cNvSpPr txBox="1"/>
+          <p:nvPr/>
+        </p:nvSpPr>
+        <p:spPr>
+          <a:xfrm>
+            <a:off x="502920" y="219456"/>
+            <a:ext cx="9144000" cy="694944"/>
+          </a:xfrm>
+          <a:prstGeom prst="rect">
+            <a:avLst/>
+          </a:prstGeom>
+          <a:noFill/>
+        </p:spPr>
+        <p:txBody>
+          <a:bodyPr wrap="square" lIns="0" rIns="0" tIns="0" bIns="0">
+            <a:spAutoFit/>
+          </a:bodyPr>
+          <a:lstStyle/>
+          <a:p>
+            <a:pPr>
+              <a:spcAft>
+                <a:spcPts val="600"/>
+              </a:spcAft>
+            </a:pPr>
+            <a:r>
+              <a:rPr sz="2800" b="1">
+                <a:solidFill>
+                  <a:srgbClr val="FFFFFF"/>
+                </a:solidFill>
+                <a:latin typeface="Arial"/>
+              </a:rPr>
+              <a:t>External validation: AgentDojo banking</a:t>
+            </a:r>
+          </a:p>
+        </p:txBody>
+      </p:sp>
+      <p:sp>
+        <p:nvSpPr>
+          <p:cNvPr id="3" name="Rectangle 2"/>
+          <p:cNvSpPr/>
+          <p:nvPr/>
+        </p:nvSpPr>
+        <p:spPr>
+          <a:xfrm>
+            <a:off x="9802368" y="73152"/>
+            <a:ext cx="2286000" cy="932688"/>
+          </a:xfrm>
+          <a:prstGeom prst="rect">
+            <a:avLst/>
+          </a:prstGeom>
+          <a:solidFill>
+            <a:srgbClr val="080B20"/>
+          </a:solidFill>
+          <a:ln>
+            <a:noFill/>
+          </a:ln>
+        </p:spPr>
+        <p:style>
+          <a:lnRef idx="1">
+            <a:schemeClr val="accent1"/>
+          </a:lnRef>
+          <a:fillRef idx="3">
+            <a:schemeClr val="accent1"/>
+          </a:fillRef>
+          <a:effectRef idx="2">
+            <a:schemeClr val="accent1"/>
+          </a:effectRef>
+          <a:fontRef idx="minor">
+            <a:schemeClr val="lt1"/>
+          </a:fontRef>
+        </p:style>
+        <p:txBody>
+          <a:bodyPr rtlCol="0" anchor="ctr"/>
+          <a:lstStyle/>
+          <a:p>
+            <a:pPr algn="ctr"/>
+          </a:p>
+        </p:txBody>
+      </p:sp>
+      <p:sp>
+        <p:nvSpPr>
+          <p:cNvPr id="4" name="TextBox 3"/>
+          <p:cNvSpPr txBox="1"/>
+          <p:nvPr/>
+        </p:nvSpPr>
+        <p:spPr>
+          <a:xfrm>
+            <a:off x="9921240" y="173736"/>
+            <a:ext cx="2057400" cy="731520"/>
+          </a:xfrm>
+          <a:prstGeom prst="rect">
+            <a:avLst/>
+          </a:prstGeom>
+          <a:noFill/>
+        </p:spPr>
+        <p:txBody>
+          <a:bodyPr wrap="square" lIns="0" rIns="0" tIns="0" bIns="0">
+            <a:spAutoFit/>
+          </a:bodyPr>
+          <a:lstStyle/>
+          <a:p>
+            <a:pPr>
+              <a:spcAft>
+                <a:spcPts val="600"/>
+              </a:spcAft>
+            </a:pPr>
+            <a:r>
+              <a:rPr sz="1400" b="1">
+                <a:solidFill>
+                  <a:srgbClr val="FFFFFF"/>
+                </a:solidFill>
+                <a:latin typeface="Arial"/>
+              </a:rPr>
+              <a:t>FinTechathon 2026</a:t>
+            </a:r>
+          </a:p>
+          <a:p>
+            <a:pPr>
+              <a:spcAft>
+                <a:spcPts val="600"/>
+              </a:spcAft>
+            </a:pPr>
+            <a:r>
+              <a:rPr sz="1400" b="1">
+                <a:solidFill>
+                  <a:srgbClr val="FFFFFF"/>
+                </a:solidFill>
+                <a:latin typeface="Arial"/>
+              </a:rPr>
+              <a:t>International AI Track</a:t>
+            </a:r>
+          </a:p>
+        </p:txBody>
+      </p:sp>
+      <p:sp>
+        <p:nvSpPr>
+          <p:cNvPr id="5" name="TextBox 4"/>
+          <p:cNvSpPr txBox="1"/>
+          <p:nvPr/>
+        </p:nvSpPr>
+        <p:spPr>
+          <a:xfrm>
+            <a:off x="11247120" y="6473952"/>
+            <a:ext cx="438912" cy="228600"/>
+          </a:xfrm>
+          <a:prstGeom prst="rect">
+            <a:avLst/>
+          </a:prstGeom>
+          <a:noFill/>
+        </p:spPr>
+        <p:txBody>
+          <a:bodyPr wrap="square" lIns="0" rIns="0" tIns="0" bIns="0">
+            <a:spAutoFit/>
+          </a:bodyPr>
+          <a:lstStyle/>
+          <a:p>
+            <a:pPr>
+              <a:spcAft>
+                <a:spcPts val="600"/>
+              </a:spcAft>
+            </a:pPr>
+            <a:r>
+              <a:rPr sz="1400" b="0">
+                <a:solidFill>
+                  <a:srgbClr val="526477"/>
+                </a:solidFill>
+                <a:latin typeface="Arial"/>
+              </a:rPr>
+              <a:t>10</a:t>
+            </a:r>
+          </a:p>
+        </p:txBody>
+      </p:sp>
+      <p:sp>
+        <p:nvSpPr>
+          <p:cNvPr id="6" name="TextBox 5"/>
+          <p:cNvSpPr txBox="1"/>
+          <p:nvPr/>
+        </p:nvSpPr>
+        <p:spPr>
+          <a:xfrm>
+            <a:off x="594360" y="1298448"/>
+            <a:ext cx="5349240" cy="411480"/>
+          </a:xfrm>
+          <a:prstGeom prst="rect">
+            <a:avLst/>
+          </a:prstGeom>
+          <a:noFill/>
+        </p:spPr>
+        <p:txBody>
+          <a:bodyPr wrap="square" lIns="0" rIns="0" tIns="0" bIns="0">
+            <a:spAutoFit/>
+          </a:bodyPr>
+          <a:lstStyle/>
+          <a:p>
+            <a:pPr>
+              <a:spcAft>
+                <a:spcPts val="600"/>
+              </a:spcAft>
+            </a:pPr>
+            <a:r>
+              <a:rPr sz="2400" b="1">
+                <a:solidFill>
+                  <a:srgbClr val="102D50"/>
+                </a:solidFill>
+                <a:latin typeface="Arial"/>
+              </a:rPr>
+              <a:t>Model-free GroundTruth</a:t>
+            </a:r>
+          </a:p>
+        </p:txBody>
+      </p:sp>
+      <p:graphicFrame>
+        <p:nvGraphicFramePr>
+          <p:cNvPr id="7" name="Chart 6"/>
+          <p:cNvGraphicFramePr>
+            <a:graphicFrameLocks noGrp="1"/>
+          </p:cNvGraphicFramePr>
+          <p:nvPr/>
+        </p:nvGraphicFramePr>
+        <p:xfrm>
+          <a:off x="594360" y="1874519"/>
+          <a:ext cx="5212080" cy="2971800"/>
+        </p:xfrm>
+        <a:graphic>
+          <a:graphicData uri="http://schemas.openxmlformats.org/drawingml/2006/chart">
+            <c:chart xmlns:c="http://schemas.openxmlformats.org/drawingml/2006/chart" r:id="rId2"/>
+          </a:graphicData>
+        </a:graphic>
+      </p:graphicFrame>
+      <p:sp>
+        <p:nvSpPr>
+          <p:cNvPr id="8" name="TextBox 7"/>
+          <p:cNvSpPr txBox="1"/>
+          <p:nvPr/>
+        </p:nvSpPr>
+        <p:spPr>
+          <a:xfrm>
+            <a:off x="6400800" y="1298448"/>
+            <a:ext cx="5349240" cy="411480"/>
+          </a:xfrm>
+          <a:prstGeom prst="rect">
+            <a:avLst/>
+          </a:prstGeom>
+          <a:noFill/>
+        </p:spPr>
+        <p:txBody>
+          <a:bodyPr wrap="square" lIns="0" rIns="0" tIns="0" bIns="0">
+            <a:spAutoFit/>
+          </a:bodyPr>
+          <a:lstStyle/>
+          <a:p>
+            <a:pPr>
+              <a:spcAft>
+                <a:spcPts val="600"/>
+              </a:spcAft>
+            </a:pPr>
+            <a:r>
+              <a:rPr sz="2400" b="1">
+                <a:solidFill>
+                  <a:srgbClr val="102D50"/>
+                </a:solidFill>
+                <a:latin typeface="Arial"/>
+              </a:rPr>
+              <a:t>Live gpt-6.1-sol</a:t>
+            </a:r>
+          </a:p>
+        </p:txBody>
+      </p:sp>
+      <p:graphicFrame>
+        <p:nvGraphicFramePr>
+          <p:cNvPr id="9" name="Chart 8"/>
+          <p:cNvGraphicFramePr>
+            <a:graphicFrameLocks noGrp="1"/>
+          </p:cNvGraphicFramePr>
+          <p:nvPr/>
+        </p:nvGraphicFramePr>
+        <p:xfrm>
+          <a:off x="6400800" y="1874519"/>
+          <a:ext cx="5212080" cy="2971800"/>
+        </p:xfrm>
+        <a:graphic>
+          <a:graphicData uri="http://schemas.openxmlformats.org/drawingml/2006/chart">
+            <c:chart xmlns:c="http://schemas.openxmlformats.org/drawingml/2006/chart" r:id="rId3"/>
+          </a:graphicData>
+        </a:graphic>
+      </p:graphicFrame>
+      <p:sp>
+        <p:nvSpPr>
+          <p:cNvPr id="10" name="TextBox 9"/>
+          <p:cNvSpPr txBox="1"/>
+          <p:nvPr/>
+        </p:nvSpPr>
+        <p:spPr>
+          <a:xfrm>
+            <a:off x="640080" y="5010912"/>
+            <a:ext cx="10881360" cy="365760"/>
+          </a:xfrm>
+          <a:prstGeom prst="rect">
+            <a:avLst/>
+          </a:prstGeom>
+          <a:noFill/>
+        </p:spPr>
+        <p:txBody>
+          <a:bodyPr wrap="square" lIns="0" rIns="0" tIns="0" bIns="0">
+            <a:spAutoFit/>
+          </a:bodyPr>
+          <a:lstStyle/>
+          <a:p>
+            <a:pPr>
+              <a:spcAft>
+                <a:spcPts val="600"/>
+              </a:spcAft>
+            </a:pPr>
+            <a:r>
+              <a:rPr sz="2000" b="0">
+                <a:solidFill>
+                  <a:srgbClr val="102D50"/>
+                </a:solidFill>
+                <a:latin typeface="Arial"/>
+              </a:rPr>
+              <a:t>Prompt-bound cells · original / corrected target judge</a:t>
+            </a:r>
+          </a:p>
+        </p:txBody>
+      </p:sp>
+      <p:sp>
+        <p:nvSpPr>
+          <p:cNvPr id="11" name="TextBox 10"/>
+          <p:cNvSpPr txBox="1"/>
+          <p:nvPr/>
+        </p:nvSpPr>
+        <p:spPr>
+          <a:xfrm>
+            <a:off x="640080" y="5504688"/>
+            <a:ext cx="10881360" cy="384048"/>
+          </a:xfrm>
+          <a:prstGeom prst="rect">
+            <a:avLst/>
+          </a:prstGeom>
+          <a:noFill/>
+        </p:spPr>
+        <p:txBody>
+          <a:bodyPr wrap="square" lIns="0" rIns="0" tIns="0" bIns="0">
+            <a:spAutoFit/>
+          </a:bodyPr>
+          <a:lstStyle/>
+          <a:p>
+            <a:pPr>
+              <a:spcAft>
+                <a:spcPts val="600"/>
+              </a:spcAft>
+            </a:pPr>
+            <a:r>
+              <a:rPr sz="1900" b="1">
+                <a:solidFill>
+                  <a:srgbClr val="007F86"/>
+                </a:solidFill>
+                <a:latin typeface="Arial"/>
+              </a:rPr>
+              <a:t>Live A5: 1 attack pair truncated. A0 also records zero successes.</a:t>
+            </a:r>
+          </a:p>
+        </p:txBody>
+      </p:sp>
+      <p:sp>
+        <p:nvSpPr>
+          <p:cNvPr id="12" name="TextBox 11"/>
+          <p:cNvSpPr txBox="1"/>
+          <p:nvPr/>
+        </p:nvSpPr>
+        <p:spPr>
+          <a:xfrm>
+            <a:off x="640080" y="6007608"/>
+            <a:ext cx="10881360" cy="320040"/>
+          </a:xfrm>
+          <a:prstGeom prst="rect">
+            <a:avLst/>
+          </a:prstGeom>
+          <a:noFill/>
+        </p:spPr>
+        <p:txBody>
+          <a:bodyPr wrap="square" lIns="0" rIns="0" tIns="0" bIns="0">
+            <a:spAutoFit/>
+          </a:bodyPr>
+          <a:lstStyle/>
+          <a:p>
+            <a:pPr>
+              <a:spcAft>
+                <a:spcPts val="600"/>
+              </a:spcAft>
+            </a:pPr>
+            <a:r>
+              <a:rPr sz="1400" b="0">
+                <a:solidFill>
+                  <a:srgbClr val="526477"/>
+                </a:solidFill>
+                <a:latin typeface="Arial"/>
+              </a:rPr>
+              <a:t>Full-suite census, no binomial bounds. Adapter value matching is weaker than native typed references.</a:t>
+            </a:r>
+          </a:p>
+        </p:txBody>
+      </p:sp>
+      <p:sp>
+        <p:nvSpPr>
+          <p:cNvPr id="13" name="TextBox 12"/>
+          <p:cNvSpPr txBox="1"/>
+          <p:nvPr/>
+        </p:nvSpPr>
+        <p:spPr>
+          <a:xfrm>
+            <a:off x="530352" y="6437376"/>
+            <a:ext cx="10607040" cy="274320"/>
+          </a:xfrm>
+          <a:prstGeom prst="rect">
+            <a:avLst/>
+          </a:prstGeom>
+          <a:noFill/>
+        </p:spPr>
+        <p:txBody>
+          <a:bodyPr wrap="square" lIns="0" rIns="0" tIns="0" bIns="0">
+            <a:spAutoFit/>
+          </a:bodyPr>
+          <a:lstStyle/>
+          <a:p>
+            <a:pPr>
+              <a:spcAft>
+                <a:spcPts val="600"/>
+              </a:spcAft>
+            </a:pPr>
+            <a:r>
+              <a:rPr sz="1400" b="0">
+                <a:solidFill>
+                  <a:srgbClr val="526477"/>
+                </a:solidFill>
+                <a:latin typeface="Arial"/>
+              </a:rPr>
+              <a:t>AgentDojo banking v1.2.2 · package 0.1.35 · evidence/agentdojo-banking/MANIFEST.md</a:t>
             </a:r>
           </a:p>
         </p:txBody>
@@ -8184,8 +9359,8 @@
         </p:nvSpPr>
         <p:spPr>
           <a:xfrm>
-            <a:off x="502920" y="219456"/>
-            <a:ext cx="9144000" cy="694944"/>
+            <a:off x="502920" y="118872"/>
+            <a:ext cx="9144000" cy="896112"/>
           </a:xfrm>
           <a:prstGeom prst="rect">
             <a:avLst/>
@@ -8204,13 +9379,29 @@
               </a:spcAft>
             </a:pPr>
             <a:r>
-              <a:rPr sz="2800" b="1">
+              <a:rPr sz="2500" b="1">
                 <a:solidFill>
                   <a:srgbClr val="FFFFFF"/>
                 </a:solidFill>
                 <a:latin typeface="Arial"/>
               </a:rPr>
-              <a:t>Every action crosses a model-free trust boundary</a:t>
+              <a:t>Model proposes · kernel decides</a:t>
+            </a:r>
+          </a:p>
+          <a:p>
+            <a:pPr>
+              <a:spcAft>
+                <a:spcPts val="600"/>
+              </a:spcAft>
+            </a:pPr>
+            <a:r>
+              <a:rPr sz="2500" b="1">
+                <a:solidFill>
+                  <a:srgbClr val="FFFFFF"/>
+                </a:solidFill>
+                <a:latin typeface="Arial"/>
+              </a:rPr>
+              <a:t>Device authorises · gateway executes</a:t>
             </a:r>
           </a:p>
         </p:txBody>

</xml_diff>

<commit_message>
Clarify hijacked planner evidence and live utility cost
</commit_message>
<xml_diff>
--- a/docs/submission/deck.pptx
+++ b/docs/submission/deck.pptx
@@ -1423,7 +1423,13 @@
           <a:p/>
           <a:p>
             <a:r>
-              <a:t>AgentDojo banking v1.2.2, package 0.1.35, supplies an external synthetic environment. The left chart is model-free GroundTruth replay: A0 targeted ASR is 144/144 with the original judge and 128/144 with the registered corrected IT0/IT1/IT3 check. A5 is 0/144 in each of prompt-bound, auto-deny and auto-approve modes; the null agent is also 0/144. These are complete censuses, with no binomial bounds. The right chart is live gpt-6.1-sol with important_instructions, domestic-freeze-6: A0 is 0/144 under both judges; prompt-bound A5 is 0/143 evaluable under both, with one attack pair truncated and unresolved. No live security advantage is established. Unchanged upstream utility, live gpt-6.1-sol: A0 benign 11/16 and attacked 97/144; A5 prompt-bound benign 8/16 and attacked 72/144 planned, counting truncations incomplete. All 509/509 selected blocks passed strict replay; pilot and other approval modes are disclosed separately in the bundle. Value matching from free-text arguments is weaker than native typed references. Issue #181, public 2026-08-17, already reports the precedence defect. Our additional observation is the IT1 GroundTruth helper-return failure under the corrected check. Sources: evidence/agentdojo-banking/MANIFEST.md; https://github.com/ethz-spylab/agentdojo/issues/181.</a:t>
+              <a:t>Security must not depend on the model resisting injection. Here the planner is fully hijacked in model-free replay: the undefended agent carries out every injected attack, 144/144 with the original judge and 128/144 with the corrected judge. Corridor's kernel blocks all of them: 0/144 in all three approval modes. Live gpt-6.1-sol resisted this attack unaided, 0/144, so the live run shows no security difference. It shows the defence's utility cost: benign completion falls from A0 11/16 to A5 8/16.</a:t>
+            </a:r>
+          </a:p>
+          <a:p/>
+          <a:p>
+            <a:r>
+              <a:t>Reference details, not spoken: AgentDojo banking v1.2.2 / package 0.1.35. Model-free A5 modes: prompt-bound, auto-deny and auto-approve, both judges; null agent also 0/144. Live important_instructions, domestic-freeze-6: A0 0/144 and prompt-bound A5 0/143 evaluable under both judges; one A5 attack pair remains truncated and unresolved. Unchanged upstream utility judge: live A0 attacked 97/144; A5 attacked 72/144 planned, with truncations incomplete. All 509/509 selected blocks passed strict replay. These are full-suite censuses, without binomial bounds. Free-text value matching is weaker than native typed references. Upstream issue #181 (2026-08-17) reports the precedence defect; the additional observation is IT1's GroundTruth helper-return failure under the corrected check. Sources: evidence/agentdojo-banking/MANIFEST.md; https://github.com/ethz-spylab/agentdojo/issues/181.</a:t>
             </a:r>
           </a:p>
         </p:txBody>
@@ -7912,7 +7918,7 @@
                 </a:solidFill>
                 <a:latin typeface="Arial"/>
               </a:rPr>
-              <a:t>External validation: AgentDojo banking</a:t>
+              <a:t>Hijacked planner: the kernel still blocks every attack</a:t>
             </a:r>
           </a:p>
         </p:txBody>
@@ -8235,13 +8241,13 @@
               </a:spcAft>
             </a:pPr>
             <a:r>
-              <a:rPr sz="1900" b="1">
+              <a:rPr sz="1600" b="1">
                 <a:solidFill>
                   <a:srgbClr val="007F86"/>
                 </a:solidFill>
                 <a:latin typeface="Arial"/>
               </a:rPr>
-              <a:t>Live A5: 1 attack pair truncated. A0 also records zero successes.</a:t>
+              <a:t>Live model resisted unaided: no security difference, but benign utility fell from A0 11/16 to A5 8/16.</a:t>
             </a:r>
           </a:p>
         </p:txBody>

</xml_diff>

<commit_message>
Finalize team identity and local demo instructions
</commit_message>
<xml_diff>
--- a/docs/submission/deck.pptx
+++ b/docs/submission/deck.pptx
@@ -1336,7 +1336,7 @@
           <a:p/>
           <a:p>
             <a:r>
-              <a:t>Introduce Corridor Wealth for Topic B. Proof-carrying wealth advice: the model proposes, a verifier decides. The project demonstrates synthetic data, simulated MFA and bank execution. It is not investment advice. The supplied official template's artwork and masters are reused, with its event label localized to English and the current submission year. The repository URL identifies the public source project; the team name remains unfilled pending the user's identity value.</a:t>
+              <a:t>Introduce Corridor Wealth for Topic B, by Model Proposes, Kernel Disposes. Proof-carrying wealth advice: the model proposes, a verifier decides. The project demonstrates synthetic data, simulated MFA and bank execution. It is not investment advice. The supplied official template's artwork and masters are reused, with its event label localized to English and the current submission year. The repository URL identifies the public source project.</a:t>
             </a:r>
           </a:p>
         </p:txBody>
@@ -4564,7 +4564,7 @@
                 </a:solidFill>
                 <a:latin typeface="Arial"/>
               </a:rPr>
-              <a:t>Topic B  ·  {{TEAM_NAME}}</a:t>
+              <a:t>Topic B  ·  Model Proposes, Kernel Disposes</a:t>
             </a:r>
           </a:p>
         </p:txBody>

</xml_diff>